<commit_message>
Resultados v1.2: re-run completo del pipeline (01-18 + checklist STROBE)
Base analitica 25 088 adultos (B7: -1 excluido, 20 conservan su PA real y dejan de contar como
hipertensos; denominador HTA-ESH 7 756 -> 7 735). Cobertura nacional 2 466-2 469 municipios
(99,5-99,6%; A2 recupera los 18 de CLUES). Cifras nacionales directas se mueven <= 0,2 pp:
prevalencia ESH 27,3 (26,2-28,4), conciencia 65,9, tratamiento 81,0, control 64,0 / 40,6.
Reclasificacion: mediana -23,2 / -25,3 pp, DE 1,6. OR de pobreza por +10 pp: 0,92-0,94, los 4 IC
excluyen el 1. Phi: 0,12 / 0,06 / 0,81 / 0,65 / 0,51. Los n de los modelos: 7 727 / 11 583 /
5 203 / 4 382 (C1). Figuras 1-3, S1-S2, tablas y checklist regenerados desde estos outputs.

El manuscrito (.md) sigue con cifras v1.1: la Fase C se hace con
_TRABAJO_INTERNO/diff_v11_v12.md delante (no versionado).
</commit_message>
<xml_diff>
--- a/FIGURAS/Fig1_flujo_STROBE.pptx
+++ b/FIGURAS/Fig1_flujo_STROBE.pptx
@@ -2796,8 +2796,8 @@
           </p:nvSpPr>
           <p:spPr>
             <a:xfrm>
-              <a:off x="1923726" y="2408902"/>
-              <a:ext cx="540318" cy="82661"/>
+              <a:off x="1919428" y="2408902"/>
+              <a:ext cx="548914" cy="82661"/>
             </a:xfrm>
             <a:prstGeom prst="rect">
               <a:avLst/>
@@ -2826,7 +2826,7 @@
                   <a:latin typeface="Arial"/>
                   <a:cs typeface="Arial"/>
                 </a:rPr>
-                <a:t>n = 25 411</a:t>
+                <a:t>n = 25 410</a:t>
               </a:r>
             </a:p>
           </p:txBody>
@@ -2912,7 +2912,7 @@
                   <a:latin typeface="Arial"/>
                   <a:cs typeface="Arial"/>
                 </a:rPr>
-                <a:t>n = 25 090</a:t>
+                <a:t>n = 25 089</a:t>
               </a:r>
             </a:p>
           </p:txBody>
@@ -3041,7 +3041,7 @@
                   <a:latin typeface="Arial"/>
                   <a:cs typeface="Arial"/>
                 </a:rPr>
-                <a:t>n = 25 089</a:t>
+                <a:t>n = 25 088</a:t>
               </a:r>
             </a:p>
           </p:txBody>
@@ -3170,7 +3170,7 @@
                   <a:latin typeface="Arial"/>
                   <a:cs typeface="Arial"/>
                 </a:rPr>
-                <a:t>n = 7 756</a:t>
+                <a:t>n = 7 735</a:t>
               </a:r>
             </a:p>
           </p:txBody>
@@ -3256,7 +3256,7 @@
                   <a:latin typeface="Arial"/>
                   <a:cs typeface="Arial"/>
                 </a:rPr>
-                <a:t>n = 5 204</a:t>
+                <a:t>n = 5 203</a:t>
               </a:r>
             </a:p>
           </p:txBody>
@@ -3385,7 +3385,7 @@
                   <a:latin typeface="Arial"/>
                   <a:cs typeface="Arial"/>
                 </a:rPr>
-                <a:t>n = 4 389</a:t>
+                <a:t>n = 4 388</a:t>
               </a:r>
             </a:p>
           </p:txBody>
@@ -4301,7 +4301,7 @@
                   <a:latin typeface="Arial"/>
                   <a:cs typeface="Arial"/>
                 </a:rPr>
-                <a:t>Excluidos: 19 600</a:t>
+                <a:t>Excluidos: 19 601</a:t>
               </a:r>
             </a:p>
           </p:txBody>
@@ -4559,7 +4559,7 @@
                   <a:latin typeface="Arial"/>
                   <a:cs typeface="Arial"/>
                 </a:rPr>
-                <a:t>Excluidos: 2 552</a:t>
+                <a:t>Excluidos: 2 532</a:t>
               </a:r>
             </a:p>
           </p:txBody>

</xml_diff>